<commit_message>
Quell-MD-Hygiene: M15/M21/M22 neu gesynct (AB-Struktur + M22 Web-Agenda)
Co-Authored-By: Claude Opus 4.8 <noreply@anthropic.com>
</commit_message>
<xml_diff>
--- a/protected-downloads/praesentation/M15.pptx
+++ b/protected-downloads/praesentation/M15.pptx
@@ -8424,7 +8424,7 @@
                 </a:solidFill>
                 <a:latin typeface="Source Serif 4"/>
               </a:rPr>
-              <a:t>AB-2: Marktbearbeitungs-Jahresplan</a:t>
+              <a:t>AB-3: Marktbearbeitungs-Jahresplan</a:t>
             </a:r>
           </a:p>
         </p:txBody>
@@ -8718,7 +8718,7 @@
                 </a:solidFill>
                 <a:latin typeface="Source Serif 4"/>
               </a:rPr>
-              <a:t>AB-2: Marktbearbeitungs-Jahresplan</a:t>
+              <a:t>AB-3: Marktbearbeitungs-Jahresplan</a:t>
             </a:r>
           </a:p>
         </p:txBody>

</xml_diff>